<commit_message>
Rebuild video intro to end on the redesigned deck cover
The intro now plays on the midnight cover background: the real mean
spectrum draws itself, then settles into the cover's bottom spectral
band while the cover (pill, short title, question, subtitle, prereq,
hero figure card) builds in. Cover title and hero geometry come from
lesson-manifest.json, written by build_course_slides.js, so intro and
deck stay in sync. Adds L05A and a new series card.

Co-Authored-By: Claude Opus 5.5 <noreply@anthropic.com>
Claude-Session: https://claude.ai/code/session_01XcT4uVZExPomXQBSRkeXb7
</commit_message>
<xml_diff>
--- a/slides/decks/L00-environment.pptx
+++ b/slides/decks/L00-environment.pptx
@@ -118,13 +118,13 @@
   <p:extLst>
     <p:ext uri="{521415D9-36F7-43E2-AB2F-B90AF26B5E84}">
       <p14:sectionLst xmlns:p14="http://schemas.microsoft.com/office/powerpoint/2010/main">
-        <p14:section name="开场" id="{09177fc3-e79a-b3d7-b3df-4d56a53e0e68}">
+        <p14:section name="开场" id="{82688725-2ce1-b081-2ce0-27c74d399880}">
           <p14:sldIdLst>
             <p14:sldId id="256"/>
             <p14:sldId id="257"/>
           </p14:sldIdLst>
         </p14:section>
-        <p14:section name="讲解" id="{dfdc39de-9539-753f-fa1e-1702d5a773fc}">
+        <p14:section name="讲解" id="{03d4eb3c-bc56-cc8b-a236-cbf7f80717b9}">
           <p14:sldIdLst>
             <p14:sldId id="258"/>
             <p14:sldId id="259"/>
@@ -135,13 +135,13 @@
             <p14:sldId id="264"/>
           </p14:sldIdLst>
         </p14:section>
-        <p14:section name="练习" id="{064a1cb9-3814-38db-0195-0172fd6acc16}">
+        <p14:section name="练习" id="{9f2b112b-40ed-8f15-8869-6803c2dfb396}">
           <p14:sldIdLst>
             <p14:sldId id="265"/>
             <p14:sldId id="266"/>
           </p14:sldIdLst>
         </p14:section>
-        <p14:section name="收束" id="{f1db68b1-14fb-8dbc-9b8f-6b1be5cdc180}">
+        <p14:section name="收束" id="{50a9ca1b-1c46-49d3-792f-cc90c5179bac}">
           <p14:sldIdLst>
             <p14:sldId id="267"/>
           </p14:sldIdLst>

</xml_diff>